<commit_message>
get list of ensemble errors
</commit_message>
<xml_diff>
--- a/data/qa_dataset/results/figures.pptx
+++ b/data/qa_dataset/results/figures.pptx
@@ -6,6 +6,7 @@
   </p:sldMasterIdLst>
   <p:sldIdLst>
     <p:sldId id="256" r:id="rId2"/>
+    <p:sldId id="257" r:id="rId3"/>
   </p:sldIdLst>
   <p:sldSz cx="12192000" cy="6858000"/>
   <p:notesSz cx="6858000" cy="9144000"/>
@@ -3323,10 +3324,10 @@
       </p:grpSpPr>
       <p:pic>
         <p:nvPicPr>
-          <p:cNvPr id="33" name="Picture 32">
-            <a:extLst>
-              <a:ext uri="{FF2B5EF4-FFF2-40B4-BE49-F238E27FC236}">
-                <a16:creationId xmlns:a16="http://schemas.microsoft.com/office/drawing/2014/main" id="{2F0D8CB5-B708-449D-A702-EEBF28AAE94F}"/>
+          <p:cNvPr id="41" name="Picture 40">
+            <a:extLst>
+              <a:ext uri="{FF2B5EF4-FFF2-40B4-BE49-F238E27FC236}">
+                <a16:creationId xmlns:a16="http://schemas.microsoft.com/office/drawing/2014/main" id="{0E9C8659-ED4A-71FF-1EA0-5BE5D2F400E6}"/>
               </a:ext>
             </a:extLst>
           </p:cNvPr>
@@ -3343,15 +3344,15 @@
               </a:ext>
             </a:extLst>
           </a:blip>
-          <a:srcRect t="11554" r="8985"/>
+          <a:srcRect t="11918" r="9190"/>
           <a:stretch>
             <a:fillRect/>
           </a:stretch>
         </p:blipFill>
         <p:spPr>
           <a:xfrm>
-            <a:off x="-18025" y="2644486"/>
-            <a:ext cx="3569110" cy="2601269"/>
+            <a:off x="3439650" y="2502275"/>
+            <a:ext cx="3439650" cy="2502275"/>
           </a:xfrm>
           <a:prstGeom prst="rect">
             <a:avLst/>
@@ -3360,10 +3361,10 @@
       </p:pic>
       <p:pic>
         <p:nvPicPr>
-          <p:cNvPr id="35" name="Picture 34">
-            <a:extLst>
-              <a:ext uri="{FF2B5EF4-FFF2-40B4-BE49-F238E27FC236}">
-                <a16:creationId xmlns:a16="http://schemas.microsoft.com/office/drawing/2014/main" id="{3DAEBC4B-2775-8D84-1F68-C308C4561179}"/>
+          <p:cNvPr id="43" name="Picture 42">
+            <a:extLst>
+              <a:ext uri="{FF2B5EF4-FFF2-40B4-BE49-F238E27FC236}">
+                <a16:creationId xmlns:a16="http://schemas.microsoft.com/office/drawing/2014/main" id="{E3CEA318-402C-C10E-64D8-369D48182DDC}"/>
               </a:ext>
             </a:extLst>
           </p:cNvPr>
@@ -3380,15 +3381,15 @@
               </a:ext>
             </a:extLst>
           </a:blip>
-          <a:srcRect t="11511" r="8985"/>
+          <a:srcRect t="11918" r="9190"/>
           <a:stretch>
             <a:fillRect/>
           </a:stretch>
         </p:blipFill>
         <p:spPr>
           <a:xfrm>
-            <a:off x="3569110" y="2643238"/>
-            <a:ext cx="3569110" cy="2602517"/>
+            <a:off x="0" y="2502275"/>
+            <a:ext cx="3439650" cy="2502275"/>
           </a:xfrm>
           <a:prstGeom prst="rect">
             <a:avLst/>
@@ -3397,10 +3398,10 @@
       </p:pic>
       <p:pic>
         <p:nvPicPr>
-          <p:cNvPr id="37" name="Picture 36">
-            <a:extLst>
-              <a:ext uri="{FF2B5EF4-FFF2-40B4-BE49-F238E27FC236}">
-                <a16:creationId xmlns:a16="http://schemas.microsoft.com/office/drawing/2014/main" id="{BF83D767-770A-0E77-F5C6-AC039A599372}"/>
+          <p:cNvPr id="45" name="Picture 44">
+            <a:extLst>
+              <a:ext uri="{FF2B5EF4-FFF2-40B4-BE49-F238E27FC236}">
+                <a16:creationId xmlns:a16="http://schemas.microsoft.com/office/drawing/2014/main" id="{9C922AB5-62FF-7AB1-5A11-07C28B35583A}"/>
               </a:ext>
             </a:extLst>
           </p:cNvPr>
@@ -3417,15 +3418,15 @@
               </a:ext>
             </a:extLst>
           </a:blip>
-          <a:srcRect t="11511" r="8985"/>
+          <a:srcRect t="11918" r="9190"/>
           <a:stretch>
             <a:fillRect/>
           </a:stretch>
         </p:blipFill>
         <p:spPr>
           <a:xfrm>
-            <a:off x="3569110" y="52471"/>
-            <a:ext cx="3569110" cy="2602517"/>
+            <a:off x="3439650" y="-1"/>
+            <a:ext cx="3439650" cy="2502275"/>
           </a:xfrm>
           <a:prstGeom prst="rect">
             <a:avLst/>
@@ -3434,10 +3435,10 @@
       </p:pic>
       <p:pic>
         <p:nvPicPr>
-          <p:cNvPr id="39" name="Picture 38">
-            <a:extLst>
-              <a:ext uri="{FF2B5EF4-FFF2-40B4-BE49-F238E27FC236}">
-                <a16:creationId xmlns:a16="http://schemas.microsoft.com/office/drawing/2014/main" id="{8A5A82DE-4B78-CE62-3814-9AC5FDF98BA3}"/>
+          <p:cNvPr id="47" name="Picture 46">
+            <a:extLst>
+              <a:ext uri="{FF2B5EF4-FFF2-40B4-BE49-F238E27FC236}">
+                <a16:creationId xmlns:a16="http://schemas.microsoft.com/office/drawing/2014/main" id="{1B0A6D5F-F127-A870-5742-4FF5AD9ABBC8}"/>
               </a:ext>
             </a:extLst>
           </p:cNvPr>
@@ -3454,15 +3455,15 @@
               </a:ext>
             </a:extLst>
           </a:blip>
-          <a:srcRect t="11868" r="8985"/>
+          <a:srcRect t="11918" r="9190"/>
           <a:stretch>
             <a:fillRect/>
           </a:stretch>
         </p:blipFill>
         <p:spPr>
           <a:xfrm>
-            <a:off x="-18025" y="52471"/>
-            <a:ext cx="3569110" cy="2592015"/>
+            <a:off x="0" y="0"/>
+            <a:ext cx="3439650" cy="2502275"/>
           </a:xfrm>
           <a:prstGeom prst="rect">
             <a:avLst/>
@@ -3518,7 +3519,7 @@
         </p:nvSpPr>
         <p:spPr>
           <a:xfrm>
-            <a:off x="3551085" y="0"/>
+            <a:off x="3439650" y="0"/>
             <a:ext cx="521109" cy="338554"/>
           </a:xfrm>
           <a:prstGeom prst="rect">
@@ -3553,7 +3554,7 @@
         </p:nvSpPr>
         <p:spPr>
           <a:xfrm>
-            <a:off x="-36050" y="2585101"/>
+            <a:off x="-18025" y="2502274"/>
             <a:ext cx="521109" cy="338554"/>
           </a:xfrm>
           <a:prstGeom prst="rect">
@@ -3588,7 +3589,7 @@
         </p:nvSpPr>
         <p:spPr>
           <a:xfrm>
-            <a:off x="3551084" y="2586245"/>
+            <a:off x="3457674" y="2502274"/>
             <a:ext cx="521109" cy="338554"/>
           </a:xfrm>
           <a:prstGeom prst="rect">
@@ -3613,6 +3614,116 @@
     <p:extLst>
       <p:ext uri="{BB962C8B-B14F-4D97-AF65-F5344CB8AC3E}">
         <p14:creationId xmlns:p14="http://schemas.microsoft.com/office/powerpoint/2010/main" val="3518202370"/>
+      </p:ext>
+    </p:extLst>
+  </p:cSld>
+  <p:clrMapOvr>
+    <a:masterClrMapping/>
+  </p:clrMapOvr>
+</p:sld>
+</file>
+
+<file path=ppt/slides/slide2.xml><?xml version="1.0" encoding="utf-8"?>
+<p:sld xmlns:a="http://schemas.openxmlformats.org/drawingml/2006/main" xmlns:r="http://schemas.openxmlformats.org/officeDocument/2006/relationships" xmlns:p="http://schemas.openxmlformats.org/presentationml/2006/main">
+  <p:cSld>
+    <p:spTree>
+      <p:nvGrpSpPr>
+        <p:cNvPr id="1" name=""/>
+        <p:cNvGrpSpPr/>
+        <p:nvPr/>
+      </p:nvGrpSpPr>
+      <p:grpSpPr>
+        <a:xfrm>
+          <a:off x="0" y="0"/>
+          <a:ext cx="0" cy="0"/>
+          <a:chOff x="0" y="0"/>
+          <a:chExt cx="0" cy="0"/>
+        </a:xfrm>
+      </p:grpSpPr>
+      <p:sp>
+        <p:nvSpPr>
+          <p:cNvPr id="2" name="Title 1">
+            <a:extLst>
+              <a:ext uri="{FF2B5EF4-FFF2-40B4-BE49-F238E27FC236}">
+                <a16:creationId xmlns:a16="http://schemas.microsoft.com/office/drawing/2014/main" id="{A61AEB8C-90CC-9946-435C-59E9A6D20904}"/>
+              </a:ext>
+            </a:extLst>
+          </p:cNvPr>
+          <p:cNvSpPr>
+            <a:spLocks noGrp="1"/>
+          </p:cNvSpPr>
+          <p:nvPr>
+            <p:ph type="title"/>
+          </p:nvPr>
+        </p:nvSpPr>
+        <p:spPr/>
+        <p:txBody>
+          <a:bodyPr/>
+          <a:lstStyle/>
+          <a:p>
+            <a:endParaRPr lang="en-US"/>
+          </a:p>
+        </p:txBody>
+      </p:sp>
+      <p:sp>
+        <p:nvSpPr>
+          <p:cNvPr id="3" name="Content Placeholder 2">
+            <a:extLst>
+              <a:ext uri="{FF2B5EF4-FFF2-40B4-BE49-F238E27FC236}">
+                <a16:creationId xmlns:a16="http://schemas.microsoft.com/office/drawing/2014/main" id="{8F6D7C84-F465-E381-C780-9CC945888684}"/>
+              </a:ext>
+            </a:extLst>
+          </p:cNvPr>
+          <p:cNvSpPr>
+            <a:spLocks noGrp="1"/>
+          </p:cNvSpPr>
+          <p:nvPr>
+            <p:ph idx="1"/>
+          </p:nvPr>
+        </p:nvSpPr>
+        <p:spPr/>
+        <p:txBody>
+          <a:bodyPr/>
+          <a:lstStyle/>
+          <a:p>
+            <a:endParaRPr lang="en-US"/>
+          </a:p>
+        </p:txBody>
+      </p:sp>
+      <p:pic>
+        <p:nvPicPr>
+          <p:cNvPr id="5" name="Picture 4">
+            <a:extLst>
+              <a:ext uri="{FF2B5EF4-FFF2-40B4-BE49-F238E27FC236}">
+                <a16:creationId xmlns:a16="http://schemas.microsoft.com/office/drawing/2014/main" id="{A542A7A5-5357-FFA6-D177-9F85776D97FE}"/>
+              </a:ext>
+            </a:extLst>
+          </p:cNvPr>
+          <p:cNvPicPr>
+            <a:picLocks noChangeAspect="1"/>
+          </p:cNvPicPr>
+          <p:nvPr/>
+        </p:nvPicPr>
+        <p:blipFill>
+          <a:blip r:embed="rId2"/>
+          <a:stretch>
+            <a:fillRect/>
+          </a:stretch>
+        </p:blipFill>
+        <p:spPr>
+          <a:xfrm>
+            <a:off x="2499810" y="552048"/>
+            <a:ext cx="7192379" cy="5753903"/>
+          </a:xfrm>
+          <a:prstGeom prst="rect">
+            <a:avLst/>
+          </a:prstGeom>
+        </p:spPr>
+      </p:pic>
+    </p:spTree>
+    <p:extLst>
+      <p:ext uri="{BB962C8B-B14F-4D97-AF65-F5344CB8AC3E}">
+        <p14:creationId xmlns:p14="http://schemas.microsoft.com/office/powerpoint/2010/main" val="977402270"/>
       </p:ext>
     </p:extLst>
   </p:cSld>

</xml_diff>